<commit_message>
Align per-clip figure colors with theme
</commit_message>
<xml_diff>
--- a/doc/current/paper/presentation/paper_zh_presentation.pptx
+++ b/doc/current/paper/presentation/paper_zh_presentation.pptx
@@ -9323,8 +9323,8 @@
         </p:nvSpPr>
         <p:spPr>
           <a:xfrm>
-            <a:off x="630936" y="1271318"/>
-            <a:ext cx="10936224" cy="3510691"/>
+            <a:off x="630936" y="1886820"/>
+            <a:ext cx="10936224" cy="2279687"/>
           </a:xfrm>
           <a:prstGeom prst="rect">
             <a:avLst/>
@@ -9376,8 +9376,8 @@
         </p:blipFill>
         <p:spPr>
           <a:xfrm>
-            <a:off x="658368" y="1298750"/>
-            <a:ext cx="10881360" cy="3455827"/>
+            <a:off x="658368" y="1914252"/>
+            <a:ext cx="10881360" cy="2224823"/>
           </a:xfrm>
           <a:prstGeom prst="rect">
             <a:avLst/>

</xml_diff>

<commit_message>
Simplify proposal ablation narrative
</commit_message>
<xml_diff>
--- a/doc/current/paper/presentation/paper_zh_presentation.pptx
+++ b/doc/current/paper/presentation/paper_zh_presentation.pptx
@@ -3737,7 +3737,7 @@
                 <a:gridCol w="1591055"/>
                 <a:gridCol w="1591059"/>
               </a:tblGrid>
-              <a:tr h="594360">
+              <a:tr h="693420">
                 <a:tc>
                   <a:txBody>
                     <a:bodyPr lIns="27432" rIns="27432" tIns="18288" bIns="18288"/>
@@ -3854,7 +3854,7 @@
                   </a:tcPr>
                 </a:tc>
               </a:tr>
-              <a:tr h="594360">
+              <a:tr h="693420">
                 <a:tc>
                   <a:txBody>
                     <a:bodyPr lIns="27432" rIns="27432" tIns="18288" bIns="18288"/>
@@ -3868,7 +3868,7 @@
                           </a:solidFill>
                           <a:latin typeface="Microsoft YaHei"/>
                         </a:rPr>
-                        <a:t>相邻帧光流</a:t>
+                        <a:t>Proposed，profile 边框</a:t>
                       </a:r>
                     </a:p>
                   </a:txBody>
@@ -3891,7 +3891,241 @@
                           </a:solidFill>
                           <a:latin typeface="Microsoft YaHei"/>
                         </a:rPr>
-                        <a:t>无物理边框线索</a:t>
+                        <a:t>完整链路</a:t>
+                      </a:r>
+                    </a:p>
+                  </a:txBody>
+                  <a:tcPr>
+                    <a:solidFill>
+                      <a:srgbClr val="FCFDFC"/>
+                    </a:solidFill>
+                  </a:tcPr>
+                </a:tc>
+                <a:tc>
+                  <a:txBody>
+                    <a:bodyPr lIns="27432" rIns="27432" tIns="18288" bIns="18288"/>
+                    <a:lstStyle/>
+                    <a:p>
+                      <a:pPr algn="ctr"/>
+                      <a:r>
+                        <a:rPr sz="800" b="0">
+                          <a:solidFill>
+                            <a:srgbClr val="1F262A"/>
+                          </a:solidFill>
+                          <a:latin typeface="Microsoft YaHei"/>
+                        </a:rPr>
+                        <a:t>3.253</a:t>
+                      </a:r>
+                    </a:p>
+                  </a:txBody>
+                  <a:tcPr>
+                    <a:solidFill>
+                      <a:srgbClr val="FCFDFC"/>
+                    </a:solidFill>
+                  </a:tcPr>
+                </a:tc>
+                <a:tc>
+                  <a:txBody>
+                    <a:bodyPr lIns="27432" rIns="27432" tIns="18288" bIns="18288"/>
+                    <a:lstStyle/>
+                    <a:p>
+                      <a:pPr algn="ctr"/>
+                      <a:r>
+                        <a:rPr sz="800" b="0">
+                          <a:solidFill>
+                            <a:srgbClr val="1F262A"/>
+                          </a:solidFill>
+                          <a:latin typeface="Microsoft YaHei"/>
+                        </a:rPr>
+                        <a:t>0.996038</a:t>
+                      </a:r>
+                    </a:p>
+                  </a:txBody>
+                  <a:tcPr>
+                    <a:solidFill>
+                      <a:srgbClr val="FCFDFC"/>
+                    </a:solidFill>
+                  </a:tcPr>
+                </a:tc>
+                <a:tc>
+                  <a:txBody>
+                    <a:bodyPr lIns="27432" rIns="27432" tIns="18288" bIns="18288"/>
+                    <a:lstStyle/>
+                    <a:p>
+                      <a:pPr algn="ctr"/>
+                      <a:r>
+                        <a:rPr sz="800" b="0">
+                          <a:solidFill>
+                            <a:srgbClr val="1F262A"/>
+                          </a:solidFill>
+                          <a:latin typeface="Microsoft YaHei"/>
+                        </a:rPr>
+                        <a:t>0.752</a:t>
+                      </a:r>
+                    </a:p>
+                  </a:txBody>
+                  <a:tcPr>
+                    <a:solidFill>
+                      <a:srgbClr val="FCFDFC"/>
+                    </a:solidFill>
+                  </a:tcPr>
+                </a:tc>
+              </a:tr>
+              <a:tr h="693420">
+                <a:tc>
+                  <a:txBody>
+                    <a:bodyPr lIns="27432" rIns="27432" tIns="18288" bIns="18288"/>
+                    <a:lstStyle/>
+                    <a:p>
+                      <a:pPr algn="ctr"/>
+                      <a:r>
+                        <a:rPr sz="800" b="0">
+                          <a:solidFill>
+                            <a:srgbClr val="1F262A"/>
+                          </a:solidFill>
+                          <a:latin typeface="Microsoft YaHei"/>
+                        </a:rPr>
+                        <a:t>去掉 LK 诊断</a:t>
+                      </a:r>
+                    </a:p>
+                  </a:txBody>
+                  <a:tcPr>
+                    <a:solidFill>
+                      <a:srgbClr val="F4F7F6"/>
+                    </a:solidFill>
+                  </a:tcPr>
+                </a:tc>
+                <a:tc>
+                  <a:txBody>
+                    <a:bodyPr lIns="27432" rIns="27432" tIns="18288" bIns="18288"/>
+                    <a:lstStyle/>
+                    <a:p>
+                      <a:pPr algn="ctr"/>
+                      <a:r>
+                        <a:rPr sz="800" b="0">
+                          <a:solidFill>
+                            <a:srgbClr val="1F262A"/>
+                          </a:solidFill>
+                          <a:latin typeface="Microsoft YaHei"/>
+                        </a:rPr>
+                        <a:t>关闭内部运动检查</a:t>
+                      </a:r>
+                    </a:p>
+                  </a:txBody>
+                  <a:tcPr>
+                    <a:solidFill>
+                      <a:srgbClr val="F4F7F6"/>
+                    </a:solidFill>
+                  </a:tcPr>
+                </a:tc>
+                <a:tc>
+                  <a:txBody>
+                    <a:bodyPr lIns="27432" rIns="27432" tIns="18288" bIns="18288"/>
+                    <a:lstStyle/>
+                    <a:p>
+                      <a:pPr algn="ctr"/>
+                      <a:r>
+                        <a:rPr sz="800" b="0">
+                          <a:solidFill>
+                            <a:srgbClr val="1F262A"/>
+                          </a:solidFill>
+                          <a:latin typeface="Microsoft YaHei"/>
+                        </a:rPr>
+                        <a:t>3.253</a:t>
+                      </a:r>
+                    </a:p>
+                  </a:txBody>
+                  <a:tcPr>
+                    <a:solidFill>
+                      <a:srgbClr val="F4F7F6"/>
+                    </a:solidFill>
+                  </a:tcPr>
+                </a:tc>
+                <a:tc>
+                  <a:txBody>
+                    <a:bodyPr lIns="27432" rIns="27432" tIns="18288" bIns="18288"/>
+                    <a:lstStyle/>
+                    <a:p>
+                      <a:pPr algn="ctr"/>
+                      <a:r>
+                        <a:rPr sz="800" b="0">
+                          <a:solidFill>
+                            <a:srgbClr val="1F262A"/>
+                          </a:solidFill>
+                          <a:latin typeface="Microsoft YaHei"/>
+                        </a:rPr>
+                        <a:t>0.996038</a:t>
+                      </a:r>
+                    </a:p>
+                  </a:txBody>
+                  <a:tcPr>
+                    <a:solidFill>
+                      <a:srgbClr val="F4F7F6"/>
+                    </a:solidFill>
+                  </a:tcPr>
+                </a:tc>
+                <a:tc>
+                  <a:txBody>
+                    <a:bodyPr lIns="27432" rIns="27432" tIns="18288" bIns="18288"/>
+                    <a:lstStyle/>
+                    <a:p>
+                      <a:pPr algn="ctr"/>
+                      <a:r>
+                        <a:rPr sz="800" b="0">
+                          <a:solidFill>
+                            <a:srgbClr val="1F262A"/>
+                          </a:solidFill>
+                          <a:latin typeface="Microsoft YaHei"/>
+                        </a:rPr>
+                        <a:t>0.752</a:t>
+                      </a:r>
+                    </a:p>
+                  </a:txBody>
+                  <a:tcPr>
+                    <a:solidFill>
+                      <a:srgbClr val="F4F7F6"/>
+                    </a:solidFill>
+                  </a:tcPr>
+                </a:tc>
+              </a:tr>
+              <a:tr h="693420">
+                <a:tc>
+                  <a:txBody>
+                    <a:bodyPr lIns="27432" rIns="27432" tIns="18288" bIns="18288"/>
+                    <a:lstStyle/>
+                    <a:p>
+                      <a:pPr algn="ctr"/>
+                      <a:r>
+                        <a:rPr sz="800" b="0">
+                          <a:solidFill>
+                            <a:srgbClr val="1F262A"/>
+                          </a:solidFill>
+                          <a:latin typeface="Microsoft YaHei"/>
+                        </a:rPr>
+                        <a:t>去掉物理边框</a:t>
+                      </a:r>
+                    </a:p>
+                  </a:txBody>
+                  <a:tcPr>
+                    <a:solidFill>
+                      <a:srgbClr val="FCFDFC"/>
+                    </a:solidFill>
+                  </a:tcPr>
+                </a:tc>
+                <a:tc>
+                  <a:txBody>
+                    <a:bodyPr lIns="27432" rIns="27432" tIns="18288" bIns="18288"/>
+                    <a:lstStyle/>
+                    <a:p>
+                      <a:pPr algn="ctr"/>
+                      <a:r>
+                        <a:rPr sz="800" b="0">
+                          <a:solidFill>
+                            <a:srgbClr val="1F262A"/>
+                          </a:solidFill>
+                          <a:latin typeface="Microsoft YaHei"/>
+                        </a:rPr>
+                        <a:t>仅相邻帧光流</a:t>
                       </a:r>
                     </a:p>
                   </a:txBody>
@@ -3971,7 +4205,7 @@
                   </a:tcPr>
                 </a:tc>
               </a:tr>
-              <a:tr h="594360">
+              <a:tr h="693420">
                 <a:tc>
                   <a:txBody>
                     <a:bodyPr lIns="27432" rIns="27432" tIns="18288" bIns="18288"/>
@@ -3985,7 +4219,7 @@
                           </a:solidFill>
                           <a:latin typeface="Microsoft YaHei"/>
                         </a:rPr>
-                        <a:t>Reference-plane LK/RANSAC</a:t>
+                        <a:t>LSD 边框观测</a:t>
                       </a:r>
                     </a:p>
                   </a:txBody>
@@ -4008,7 +4242,7 @@
                           </a:solidFill>
                           <a:latin typeface="Microsoft YaHei"/>
                         </a:rPr>
-                        <a:t>无物理边框线索</a:t>
+                        <a:t>替换 profile</a:t>
                       </a:r>
                     </a:p>
                   </a:txBody>
@@ -4031,7 +4265,7 @@
                           </a:solidFill>
                           <a:latin typeface="Microsoft YaHei"/>
                         </a:rPr>
-                        <a:t>643.949</a:t>
+                        <a:t>3.604</a:t>
                       </a:r>
                     </a:p>
                   </a:txBody>
@@ -4054,7 +4288,7 @@
                           </a:solidFill>
                           <a:latin typeface="Microsoft YaHei"/>
                         </a:rPr>
-                        <a:t>0.520994</a:t>
+                        <a:t>0.995716</a:t>
                       </a:r>
                     </a:p>
                   </a:txBody>
@@ -4077,7 +4311,7 @@
                           </a:solidFill>
                           <a:latin typeface="Microsoft YaHei"/>
                         </a:rPr>
-                        <a:t>4.579</a:t>
+                        <a:t>0.961</a:t>
                       </a:r>
                     </a:p>
                   </a:txBody>
@@ -4088,7 +4322,7 @@
                   </a:tcPr>
                 </a:tc>
               </a:tr>
-              <a:tr h="594360">
+              <a:tr h="693420">
                 <a:tc>
                   <a:txBody>
                     <a:bodyPr lIns="27432" rIns="27432" tIns="18288" bIns="18288"/>
@@ -4102,241 +4336,7 @@
                           </a:solidFill>
                           <a:latin typeface="Microsoft YaHei"/>
                         </a:rPr>
-                        <a:t>Proposed，profile 边框</a:t>
-                      </a:r>
-                    </a:p>
-                  </a:txBody>
-                  <a:tcPr>
-                    <a:solidFill>
-                      <a:srgbClr val="FCFDFC"/>
-                    </a:solidFill>
-                  </a:tcPr>
-                </a:tc>
-                <a:tc>
-                  <a:txBody>
-                    <a:bodyPr lIns="27432" rIns="27432" tIns="18288" bIns="18288"/>
-                    <a:lstStyle/>
-                    <a:p>
-                      <a:pPr algn="ctr"/>
-                      <a:r>
-                        <a:rPr sz="800" b="0">
-                          <a:solidFill>
-                            <a:srgbClr val="1F262A"/>
-                          </a:solidFill>
-                          <a:latin typeface="Microsoft YaHei"/>
-                        </a:rPr>
-                        <a:t>完整方法</a:t>
-                      </a:r>
-                    </a:p>
-                  </a:txBody>
-                  <a:tcPr>
-                    <a:solidFill>
-                      <a:srgbClr val="FCFDFC"/>
-                    </a:solidFill>
-                  </a:tcPr>
-                </a:tc>
-                <a:tc>
-                  <a:txBody>
-                    <a:bodyPr lIns="27432" rIns="27432" tIns="18288" bIns="18288"/>
-                    <a:lstStyle/>
-                    <a:p>
-                      <a:pPr algn="ctr"/>
-                      <a:r>
-                        <a:rPr sz="800" b="0">
-                          <a:solidFill>
-                            <a:srgbClr val="1F262A"/>
-                          </a:solidFill>
-                          <a:latin typeface="Microsoft YaHei"/>
-                        </a:rPr>
-                        <a:t>3.253</a:t>
-                      </a:r>
-                    </a:p>
-                  </a:txBody>
-                  <a:tcPr>
-                    <a:solidFill>
-                      <a:srgbClr val="FCFDFC"/>
-                    </a:solidFill>
-                  </a:tcPr>
-                </a:tc>
-                <a:tc>
-                  <a:txBody>
-                    <a:bodyPr lIns="27432" rIns="27432" tIns="18288" bIns="18288"/>
-                    <a:lstStyle/>
-                    <a:p>
-                      <a:pPr algn="ctr"/>
-                      <a:r>
-                        <a:rPr sz="800" b="0">
-                          <a:solidFill>
-                            <a:srgbClr val="1F262A"/>
-                          </a:solidFill>
-                          <a:latin typeface="Microsoft YaHei"/>
-                        </a:rPr>
-                        <a:t>0.996038</a:t>
-                      </a:r>
-                    </a:p>
-                  </a:txBody>
-                  <a:tcPr>
-                    <a:solidFill>
-                      <a:srgbClr val="FCFDFC"/>
-                    </a:solidFill>
-                  </a:tcPr>
-                </a:tc>
-                <a:tc>
-                  <a:txBody>
-                    <a:bodyPr lIns="27432" rIns="27432" tIns="18288" bIns="18288"/>
-                    <a:lstStyle/>
-                    <a:p>
-                      <a:pPr algn="ctr"/>
-                      <a:r>
-                        <a:rPr sz="800" b="0">
-                          <a:solidFill>
-                            <a:srgbClr val="1F262A"/>
-                          </a:solidFill>
-                          <a:latin typeface="Microsoft YaHei"/>
-                        </a:rPr>
-                        <a:t>0.752</a:t>
-                      </a:r>
-                    </a:p>
-                  </a:txBody>
-                  <a:tcPr>
-                    <a:solidFill>
-                      <a:srgbClr val="FCFDFC"/>
-                    </a:solidFill>
-                  </a:tcPr>
-                </a:tc>
-              </a:tr>
-              <a:tr h="594360">
-                <a:tc>
-                  <a:txBody>
-                    <a:bodyPr lIns="27432" rIns="27432" tIns="18288" bIns="18288"/>
-                    <a:lstStyle/>
-                    <a:p>
-                      <a:pPr algn="ctr"/>
-                      <a:r>
-                        <a:rPr sz="800" b="0">
-                          <a:solidFill>
-                            <a:srgbClr val="1F262A"/>
-                          </a:solidFill>
-                          <a:latin typeface="Microsoft YaHei"/>
-                        </a:rPr>
-                        <a:t>去掉轨迹滤波</a:t>
-                      </a:r>
-                    </a:p>
-                  </a:txBody>
-                  <a:tcPr>
-                    <a:solidFill>
-                      <a:srgbClr val="F4F7F6"/>
-                    </a:solidFill>
-                  </a:tcPr>
-                </a:tc>
-                <a:tc>
-                  <a:txBody>
-                    <a:bodyPr lIns="27432" rIns="27432" tIns="18288" bIns="18288"/>
-                    <a:lstStyle/>
-                    <a:p>
-                      <a:pPr algn="ctr"/>
-                      <a:r>
-                        <a:rPr sz="800" b="0">
-                          <a:solidFill>
-                            <a:srgbClr val="1F262A"/>
-                          </a:solidFill>
-                          <a:latin typeface="Microsoft YaHei"/>
-                        </a:rPr>
-                        <a:t>移除轨迹平滑</a:t>
-                      </a:r>
-                    </a:p>
-                  </a:txBody>
-                  <a:tcPr>
-                    <a:solidFill>
-                      <a:srgbClr val="F4F7F6"/>
-                    </a:solidFill>
-                  </a:tcPr>
-                </a:tc>
-                <a:tc>
-                  <a:txBody>
-                    <a:bodyPr lIns="27432" rIns="27432" tIns="18288" bIns="18288"/>
-                    <a:lstStyle/>
-                    <a:p>
-                      <a:pPr algn="ctr"/>
-                      <a:r>
-                        <a:rPr sz="800" b="0">
-                          <a:solidFill>
-                            <a:srgbClr val="1F262A"/>
-                          </a:solidFill>
-                          <a:latin typeface="Microsoft YaHei"/>
-                        </a:rPr>
-                        <a:t>2.932</a:t>
-                      </a:r>
-                    </a:p>
-                  </a:txBody>
-                  <a:tcPr>
-                    <a:solidFill>
-                      <a:srgbClr val="F4F7F6"/>
-                    </a:solidFill>
-                  </a:tcPr>
-                </a:tc>
-                <a:tc>
-                  <a:txBody>
-                    <a:bodyPr lIns="27432" rIns="27432" tIns="18288" bIns="18288"/>
-                    <a:lstStyle/>
-                    <a:p>
-                      <a:pPr algn="ctr"/>
-                      <a:r>
-                        <a:rPr sz="800" b="0">
-                          <a:solidFill>
-                            <a:srgbClr val="1F262A"/>
-                          </a:solidFill>
-                          <a:latin typeface="Microsoft YaHei"/>
-                        </a:rPr>
-                        <a:t>0.996585</a:t>
-                      </a:r>
-                    </a:p>
-                  </a:txBody>
-                  <a:tcPr>
-                    <a:solidFill>
-                      <a:srgbClr val="F4F7F6"/>
-                    </a:solidFill>
-                  </a:tcPr>
-                </a:tc>
-                <a:tc>
-                  <a:txBody>
-                    <a:bodyPr lIns="27432" rIns="27432" tIns="18288" bIns="18288"/>
-                    <a:lstStyle/>
-                    <a:p>
-                      <a:pPr algn="ctr"/>
-                      <a:r>
-                        <a:rPr sz="800" b="0">
-                          <a:solidFill>
-                            <a:srgbClr val="1F262A"/>
-                          </a:solidFill>
-                          <a:latin typeface="Microsoft YaHei"/>
-                        </a:rPr>
-                        <a:t>1.430</a:t>
-                      </a:r>
-                    </a:p>
-                  </a:txBody>
-                  <a:tcPr>
-                    <a:solidFill>
-                      <a:srgbClr val="F4F7F6"/>
-                    </a:solidFill>
-                  </a:tcPr>
-                </a:tc>
-              </a:tr>
-              <a:tr h="594360">
-                <a:tc>
-                  <a:txBody>
-                    <a:bodyPr lIns="27432" rIns="27432" tIns="18288" bIns="18288"/>
-                    <a:lstStyle/>
-                    <a:p>
-                      <a:pPr algn="ctr"/>
-                      <a:r>
-                        <a:rPr sz="800" b="0">
-                          <a:solidFill>
-                            <a:srgbClr val="1F262A"/>
-                          </a:solidFill>
-                          <a:latin typeface="Microsoft YaHei"/>
-                        </a:rPr>
-                        <a:t>LSD 边框观测</a:t>
+                        <a:t>Hough 边框观测</a:t>
                       </a:r>
                     </a:p>
                   </a:txBody>
@@ -4382,7 +4382,7 @@
                           </a:solidFill>
                           <a:latin typeface="Microsoft YaHei"/>
                         </a:rPr>
-                        <a:t>3.604</a:t>
+                        <a:t>27.335</a:t>
                       </a:r>
                     </a:p>
                   </a:txBody>
@@ -4405,7 +4405,7 @@
                           </a:solidFill>
                           <a:latin typeface="Microsoft YaHei"/>
                         </a:rPr>
-                        <a:t>0.995716</a:t>
+                        <a:t>0.974200</a:t>
                       </a:r>
                     </a:p>
                   </a:txBody>
@@ -4428,7 +4428,7 @@
                           </a:solidFill>
                           <a:latin typeface="Microsoft YaHei"/>
                         </a:rPr>
-                        <a:t>0.961</a:t>
+                        <a:t>0.897</a:t>
                       </a:r>
                     </a:p>
                   </a:txBody>
@@ -4439,123 +4439,6 @@
                   </a:tcPr>
                 </a:tc>
               </a:tr>
-              <a:tr h="594360">
-                <a:tc>
-                  <a:txBody>
-                    <a:bodyPr lIns="27432" rIns="27432" tIns="18288" bIns="18288"/>
-                    <a:lstStyle/>
-                    <a:p>
-                      <a:pPr algn="ctr"/>
-                      <a:r>
-                        <a:rPr sz="800" b="0">
-                          <a:solidFill>
-                            <a:srgbClr val="1F262A"/>
-                          </a:solidFill>
-                          <a:latin typeface="Microsoft YaHei"/>
-                        </a:rPr>
-                        <a:t>Hough 边框观测</a:t>
-                      </a:r>
-                    </a:p>
-                  </a:txBody>
-                  <a:tcPr>
-                    <a:solidFill>
-                      <a:srgbClr val="F4F7F6"/>
-                    </a:solidFill>
-                  </a:tcPr>
-                </a:tc>
-                <a:tc>
-                  <a:txBody>
-                    <a:bodyPr lIns="27432" rIns="27432" tIns="18288" bIns="18288"/>
-                    <a:lstStyle/>
-                    <a:p>
-                      <a:pPr algn="ctr"/>
-                      <a:r>
-                        <a:rPr sz="800" b="0">
-                          <a:solidFill>
-                            <a:srgbClr val="1F262A"/>
-                          </a:solidFill>
-                          <a:latin typeface="Microsoft YaHei"/>
-                        </a:rPr>
-                        <a:t>替换 profile</a:t>
-                      </a:r>
-                    </a:p>
-                  </a:txBody>
-                  <a:tcPr>
-                    <a:solidFill>
-                      <a:srgbClr val="F4F7F6"/>
-                    </a:solidFill>
-                  </a:tcPr>
-                </a:tc>
-                <a:tc>
-                  <a:txBody>
-                    <a:bodyPr lIns="27432" rIns="27432" tIns="18288" bIns="18288"/>
-                    <a:lstStyle/>
-                    <a:p>
-                      <a:pPr algn="ctr"/>
-                      <a:r>
-                        <a:rPr sz="800" b="0">
-                          <a:solidFill>
-                            <a:srgbClr val="1F262A"/>
-                          </a:solidFill>
-                          <a:latin typeface="Microsoft YaHei"/>
-                        </a:rPr>
-                        <a:t>27.335</a:t>
-                      </a:r>
-                    </a:p>
-                  </a:txBody>
-                  <a:tcPr>
-                    <a:solidFill>
-                      <a:srgbClr val="F4F7F6"/>
-                    </a:solidFill>
-                  </a:tcPr>
-                </a:tc>
-                <a:tc>
-                  <a:txBody>
-                    <a:bodyPr lIns="27432" rIns="27432" tIns="18288" bIns="18288"/>
-                    <a:lstStyle/>
-                    <a:p>
-                      <a:pPr algn="ctr"/>
-                      <a:r>
-                        <a:rPr sz="800" b="0">
-                          <a:solidFill>
-                            <a:srgbClr val="1F262A"/>
-                          </a:solidFill>
-                          <a:latin typeface="Microsoft YaHei"/>
-                        </a:rPr>
-                        <a:t>0.974200</a:t>
-                      </a:r>
-                    </a:p>
-                  </a:txBody>
-                  <a:tcPr>
-                    <a:solidFill>
-                      <a:srgbClr val="F4F7F6"/>
-                    </a:solidFill>
-                  </a:tcPr>
-                </a:tc>
-                <a:tc>
-                  <a:txBody>
-                    <a:bodyPr lIns="27432" rIns="27432" tIns="18288" bIns="18288"/>
-                    <a:lstStyle/>
-                    <a:p>
-                      <a:pPr algn="ctr"/>
-                      <a:r>
-                        <a:rPr sz="800" b="0">
-                          <a:solidFill>
-                            <a:srgbClr val="1F262A"/>
-                          </a:solidFill>
-                          <a:latin typeface="Microsoft YaHei"/>
-                        </a:rPr>
-                        <a:t>0.897</a:t>
-                      </a:r>
-                    </a:p>
-                  </a:txBody>
-                  <a:tcPr>
-                    <a:solidFill>
-                      <a:srgbClr val="F4F7F6"/>
-                    </a:solidFill>
-                  </a:tcPr>
-                </a:tc>
-              </a:tr>
             </a:tbl>
           </a:graphicData>
         </a:graphic>
@@ -4635,7 +4518,7 @@
                 </a:solidFill>
                 <a:latin typeface="Microsoft YaHei"/>
               </a:rPr>
-              <a:t>没有物理边框线索时，连贯滚动内容会主导单应矩阵；profile 边框观测在精度和稳定性之间更均衡。</a:t>
+              <a:t>消融只保留当前实现中的可切换模块：LK 诊断、物理边框证据和边框观测器。</a:t>
             </a:r>
           </a:p>
         </p:txBody>

</xml_diff>

<commit_message>
Refine proposal ablation table
</commit_message>
<xml_diff>
--- a/doc/current/paper/presentation/paper_zh_presentation.pptx
+++ b/doc/current/paper/presentation/paper_zh_presentation.pptx
@@ -3721,8 +3721,8 @@
           <p:nvPr/>
         </p:nvGraphicFramePr>
         <p:xfrm>
-          <a:off x="658368" y="1243584"/>
-          <a:ext cx="7955279" cy="4160520"/>
+          <a:off x="658368" y="1170432"/>
+          <a:ext cx="7955279" cy="4389120"/>
         </p:xfrm>
         <a:graphic>
           <a:graphicData uri="http://schemas.openxmlformats.org/drawingml/2006/table">
@@ -3737,7 +3737,7 @@
                 <a:gridCol w="1591055"/>
                 <a:gridCol w="1591059"/>
               </a:tblGrid>
-              <a:tr h="693420">
+              <a:tr h="627017">
                 <a:tc>
                   <a:txBody>
                     <a:bodyPr lIns="27432" rIns="27432" tIns="18288" bIns="18288"/>
@@ -3745,7 +3745,7 @@
                     <a:p>
                       <a:pPr algn="ctr"/>
                       <a:r>
-                        <a:rPr sz="800" b="1">
+                        <a:rPr sz="700" b="1">
                           <a:solidFill>
                             <a:srgbClr val="10504D"/>
                           </a:solidFill>
@@ -3768,7 +3768,7 @@
                     <a:p>
                       <a:pPr algn="ctr"/>
                       <a:r>
-                        <a:rPr sz="800" b="1">
+                        <a:rPr sz="700" b="1">
                           <a:solidFill>
                             <a:srgbClr val="10504D"/>
                           </a:solidFill>
@@ -3791,7 +3791,7 @@
                     <a:p>
                       <a:pPr algn="ctr"/>
                       <a:r>
-                        <a:rPr sz="800" b="1">
+                        <a:rPr sz="700" b="1">
                           <a:solidFill>
                             <a:srgbClr val="10504D"/>
                           </a:solidFill>
@@ -3814,7 +3814,7 @@
                     <a:p>
                       <a:pPr algn="ctr"/>
                       <a:r>
-                        <a:rPr sz="800" b="1">
+                        <a:rPr sz="700" b="1">
                           <a:solidFill>
                             <a:srgbClr val="10504D"/>
                           </a:solidFill>
@@ -3837,7 +3837,7 @@
                     <a:p>
                       <a:pPr algn="ctr"/>
                       <a:r>
-                        <a:rPr sz="800" b="1">
+                        <a:rPr sz="700" b="1">
                           <a:solidFill>
                             <a:srgbClr val="10504D"/>
                           </a:solidFill>
@@ -3854,7 +3854,7 @@
                   </a:tcPr>
                 </a:tc>
               </a:tr>
-              <a:tr h="693420">
+              <a:tr h="627017">
                 <a:tc>
                   <a:txBody>
                     <a:bodyPr lIns="27432" rIns="27432" tIns="18288" bIns="18288"/>
@@ -3862,7 +3862,7 @@
                     <a:p>
                       <a:pPr algn="ctr"/>
                       <a:r>
-                        <a:rPr sz="800" b="0">
+                        <a:rPr sz="700" b="0">
                           <a:solidFill>
                             <a:srgbClr val="1F262A"/>
                           </a:solidFill>
@@ -3885,7 +3885,7 @@
                     <a:p>
                       <a:pPr algn="ctr"/>
                       <a:r>
-                        <a:rPr sz="800" b="0">
+                        <a:rPr sz="700" b="0">
                           <a:solidFill>
                             <a:srgbClr val="1F262A"/>
                           </a:solidFill>
@@ -3908,7 +3908,7 @@
                     <a:p>
                       <a:pPr algn="ctr"/>
                       <a:r>
-                        <a:rPr sz="800" b="0">
+                        <a:rPr sz="700" b="0">
                           <a:solidFill>
                             <a:srgbClr val="1F262A"/>
                           </a:solidFill>
@@ -3931,7 +3931,7 @@
                     <a:p>
                       <a:pPr algn="ctr"/>
                       <a:r>
-                        <a:rPr sz="800" b="0">
+                        <a:rPr sz="700" b="0">
                           <a:solidFill>
                             <a:srgbClr val="1F262A"/>
                           </a:solidFill>
@@ -3954,7 +3954,7 @@
                     <a:p>
                       <a:pPr algn="ctr"/>
                       <a:r>
-                        <a:rPr sz="800" b="0">
+                        <a:rPr sz="700" b="0">
                           <a:solidFill>
                             <a:srgbClr val="1F262A"/>
                           </a:solidFill>
@@ -3971,7 +3971,7 @@
                   </a:tcPr>
                 </a:tc>
               </a:tr>
-              <a:tr h="693420">
+              <a:tr h="627017">
                 <a:tc>
                   <a:txBody>
                     <a:bodyPr lIns="27432" rIns="27432" tIns="18288" bIns="18288"/>
@@ -3979,13 +3979,13 @@
                     <a:p>
                       <a:pPr algn="ctr"/>
                       <a:r>
-                        <a:rPr sz="800" b="0">
+                        <a:rPr sz="700" b="0">
                           <a:solidFill>
                             <a:srgbClr val="1F262A"/>
                           </a:solidFill>
                           <a:latin typeface="Microsoft YaHei"/>
                         </a:rPr>
-                        <a:t>去掉 LK 诊断</a:t>
+                        <a:t>去掉轨迹滤波</a:t>
                       </a:r>
                     </a:p>
                   </a:txBody>
@@ -4002,13 +4002,13 @@
                     <a:p>
                       <a:pPr algn="ctr"/>
                       <a:r>
-                        <a:rPr sz="800" b="0">
+                        <a:rPr sz="700" b="0">
                           <a:solidFill>
                             <a:srgbClr val="1F262A"/>
                           </a:solidFill>
                           <a:latin typeface="Microsoft YaHei"/>
                         </a:rPr>
-                        <a:t>关闭内部运动检查</a:t>
+                        <a:t>关闭平滑窗口</a:t>
                       </a:r>
                     </a:p>
                   </a:txBody>
@@ -4025,13 +4025,13 @@
                     <a:p>
                       <a:pPr algn="ctr"/>
                       <a:r>
-                        <a:rPr sz="800" b="0">
+                        <a:rPr sz="700" b="0">
                           <a:solidFill>
                             <a:srgbClr val="1F262A"/>
                           </a:solidFill>
                           <a:latin typeface="Microsoft YaHei"/>
                         </a:rPr>
-                        <a:t>3.253</a:t>
+                        <a:t>2.932</a:t>
                       </a:r>
                     </a:p>
                   </a:txBody>
@@ -4048,13 +4048,13 @@
                     <a:p>
                       <a:pPr algn="ctr"/>
                       <a:r>
-                        <a:rPr sz="800" b="0">
+                        <a:rPr sz="700" b="0">
                           <a:solidFill>
                             <a:srgbClr val="1F262A"/>
                           </a:solidFill>
                           <a:latin typeface="Microsoft YaHei"/>
                         </a:rPr>
-                        <a:t>0.996038</a:t>
+                        <a:t>0.996585</a:t>
                       </a:r>
                     </a:p>
                   </a:txBody>
@@ -4071,13 +4071,13 @@
                     <a:p>
                       <a:pPr algn="ctr"/>
                       <a:r>
-                        <a:rPr sz="800" b="0">
+                        <a:rPr sz="700" b="0">
                           <a:solidFill>
                             <a:srgbClr val="1F262A"/>
                           </a:solidFill>
                           <a:latin typeface="Microsoft YaHei"/>
                         </a:rPr>
-                        <a:t>0.752</a:t>
+                        <a:t>1.430</a:t>
                       </a:r>
                     </a:p>
                   </a:txBody>
@@ -4088,7 +4088,7 @@
                   </a:tcPr>
                 </a:tc>
               </a:tr>
-              <a:tr h="693420">
+              <a:tr h="627017">
                 <a:tc>
                   <a:txBody>
                     <a:bodyPr lIns="27432" rIns="27432" tIns="18288" bIns="18288"/>
@@ -4096,13 +4096,13 @@
                     <a:p>
                       <a:pPr algn="ctr"/>
                       <a:r>
-                        <a:rPr sz="800" b="0">
+                        <a:rPr sz="700" b="0">
                           <a:solidFill>
                             <a:srgbClr val="1F262A"/>
                           </a:solidFill>
                           <a:latin typeface="Microsoft YaHei"/>
                         </a:rPr>
-                        <a:t>去掉物理边框</a:t>
+                        <a:t>去掉 LK 诊断</a:t>
                       </a:r>
                     </a:p>
                   </a:txBody>
@@ -4119,13 +4119,13 @@
                     <a:p>
                       <a:pPr algn="ctr"/>
                       <a:r>
-                        <a:rPr sz="800" b="0">
+                        <a:rPr sz="700" b="0">
                           <a:solidFill>
                             <a:srgbClr val="1F262A"/>
                           </a:solidFill>
                           <a:latin typeface="Microsoft YaHei"/>
                         </a:rPr>
-                        <a:t>仅相邻帧光流</a:t>
+                        <a:t>关闭内部运动检查</a:t>
                       </a:r>
                     </a:p>
                   </a:txBody>
@@ -4142,13 +4142,13 @@
                     <a:p>
                       <a:pPr algn="ctr"/>
                       <a:r>
-                        <a:rPr sz="800" b="0">
+                        <a:rPr sz="700" b="0">
                           <a:solidFill>
                             <a:srgbClr val="1F262A"/>
                           </a:solidFill>
                           <a:latin typeface="Microsoft YaHei"/>
                         </a:rPr>
-                        <a:t>76.114</a:t>
+                        <a:t>3.253</a:t>
                       </a:r>
                     </a:p>
                   </a:txBody>
@@ -4165,13 +4165,13 @@
                     <a:p>
                       <a:pPr algn="ctr"/>
                       <a:r>
-                        <a:rPr sz="800" b="0">
+                        <a:rPr sz="700" b="0">
                           <a:solidFill>
                             <a:srgbClr val="1F262A"/>
                           </a:solidFill>
                           <a:latin typeface="Microsoft YaHei"/>
                         </a:rPr>
-                        <a:t>0.916022</a:t>
+                        <a:t>0.996038</a:t>
                       </a:r>
                     </a:p>
                   </a:txBody>
@@ -4188,13 +4188,13 @@
                     <a:p>
                       <a:pPr algn="ctr"/>
                       <a:r>
-                        <a:rPr sz="800" b="0">
+                        <a:rPr sz="700" b="0">
                           <a:solidFill>
                             <a:srgbClr val="1F262A"/>
                           </a:solidFill>
                           <a:latin typeface="Microsoft YaHei"/>
                         </a:rPr>
-                        <a:t>2.205</a:t>
+                        <a:t>0.752</a:t>
                       </a:r>
                     </a:p>
                   </a:txBody>
@@ -4205,7 +4205,7 @@
                   </a:tcPr>
                 </a:tc>
               </a:tr>
-              <a:tr h="693420">
+              <a:tr h="627017">
                 <a:tc>
                   <a:txBody>
                     <a:bodyPr lIns="27432" rIns="27432" tIns="18288" bIns="18288"/>
@@ -4213,13 +4213,13 @@
                     <a:p>
                       <a:pPr algn="ctr"/>
                       <a:r>
-                        <a:rPr sz="800" b="0">
+                        <a:rPr sz="700" b="0">
                           <a:solidFill>
                             <a:srgbClr val="1F262A"/>
                           </a:solidFill>
                           <a:latin typeface="Microsoft YaHei"/>
                         </a:rPr>
-                        <a:t>LSD 边框观测</a:t>
+                        <a:t>去掉物理边框</a:t>
                       </a:r>
                     </a:p>
                   </a:txBody>
@@ -4236,7 +4236,241 @@
                     <a:p>
                       <a:pPr algn="ctr"/>
                       <a:r>
-                        <a:rPr sz="800" b="0">
+                        <a:rPr sz="700" b="0">
+                          <a:solidFill>
+                            <a:srgbClr val="1F262A"/>
+                          </a:solidFill>
+                          <a:latin typeface="Microsoft YaHei"/>
+                        </a:rPr>
+                        <a:t>仅相邻帧光流</a:t>
+                      </a:r>
+                    </a:p>
+                  </a:txBody>
+                  <a:tcPr>
+                    <a:solidFill>
+                      <a:srgbClr val="F4F7F6"/>
+                    </a:solidFill>
+                  </a:tcPr>
+                </a:tc>
+                <a:tc>
+                  <a:txBody>
+                    <a:bodyPr lIns="27432" rIns="27432" tIns="18288" bIns="18288"/>
+                    <a:lstStyle/>
+                    <a:p>
+                      <a:pPr algn="ctr"/>
+                      <a:r>
+                        <a:rPr sz="700" b="0">
+                          <a:solidFill>
+                            <a:srgbClr val="1F262A"/>
+                          </a:solidFill>
+                          <a:latin typeface="Microsoft YaHei"/>
+                        </a:rPr>
+                        <a:t>76.114</a:t>
+                      </a:r>
+                    </a:p>
+                  </a:txBody>
+                  <a:tcPr>
+                    <a:solidFill>
+                      <a:srgbClr val="F4F7F6"/>
+                    </a:solidFill>
+                  </a:tcPr>
+                </a:tc>
+                <a:tc>
+                  <a:txBody>
+                    <a:bodyPr lIns="27432" rIns="27432" tIns="18288" bIns="18288"/>
+                    <a:lstStyle/>
+                    <a:p>
+                      <a:pPr algn="ctr"/>
+                      <a:r>
+                        <a:rPr sz="700" b="0">
+                          <a:solidFill>
+                            <a:srgbClr val="1F262A"/>
+                          </a:solidFill>
+                          <a:latin typeface="Microsoft YaHei"/>
+                        </a:rPr>
+                        <a:t>0.916022</a:t>
+                      </a:r>
+                    </a:p>
+                  </a:txBody>
+                  <a:tcPr>
+                    <a:solidFill>
+                      <a:srgbClr val="F4F7F6"/>
+                    </a:solidFill>
+                  </a:tcPr>
+                </a:tc>
+                <a:tc>
+                  <a:txBody>
+                    <a:bodyPr lIns="27432" rIns="27432" tIns="18288" bIns="18288"/>
+                    <a:lstStyle/>
+                    <a:p>
+                      <a:pPr algn="ctr"/>
+                      <a:r>
+                        <a:rPr sz="700" b="0">
+                          <a:solidFill>
+                            <a:srgbClr val="1F262A"/>
+                          </a:solidFill>
+                          <a:latin typeface="Microsoft YaHei"/>
+                        </a:rPr>
+                        <a:t>2.205</a:t>
+                      </a:r>
+                    </a:p>
+                  </a:txBody>
+                  <a:tcPr>
+                    <a:solidFill>
+                      <a:srgbClr val="F4F7F6"/>
+                    </a:solidFill>
+                  </a:tcPr>
+                </a:tc>
+              </a:tr>
+              <a:tr h="627017">
+                <a:tc>
+                  <a:txBody>
+                    <a:bodyPr lIns="27432" rIns="27432" tIns="18288" bIns="18288"/>
+                    <a:lstStyle/>
+                    <a:p>
+                      <a:pPr algn="ctr"/>
+                      <a:r>
+                        <a:rPr sz="700" b="0">
+                          <a:solidFill>
+                            <a:srgbClr val="1F262A"/>
+                          </a:solidFill>
+                          <a:latin typeface="Microsoft YaHei"/>
+                        </a:rPr>
+                        <a:t>LSD 边框观测</a:t>
+                      </a:r>
+                    </a:p>
+                  </a:txBody>
+                  <a:tcPr>
+                    <a:solidFill>
+                      <a:srgbClr val="FCFDFC"/>
+                    </a:solidFill>
+                  </a:tcPr>
+                </a:tc>
+                <a:tc>
+                  <a:txBody>
+                    <a:bodyPr lIns="27432" rIns="27432" tIns="18288" bIns="18288"/>
+                    <a:lstStyle/>
+                    <a:p>
+                      <a:pPr algn="ctr"/>
+                      <a:r>
+                        <a:rPr sz="700" b="0">
+                          <a:solidFill>
+                            <a:srgbClr val="1F262A"/>
+                          </a:solidFill>
+                          <a:latin typeface="Microsoft YaHei"/>
+                        </a:rPr>
+                        <a:t>替换 profile</a:t>
+                      </a:r>
+                    </a:p>
+                  </a:txBody>
+                  <a:tcPr>
+                    <a:solidFill>
+                      <a:srgbClr val="FCFDFC"/>
+                    </a:solidFill>
+                  </a:tcPr>
+                </a:tc>
+                <a:tc>
+                  <a:txBody>
+                    <a:bodyPr lIns="27432" rIns="27432" tIns="18288" bIns="18288"/>
+                    <a:lstStyle/>
+                    <a:p>
+                      <a:pPr algn="ctr"/>
+                      <a:r>
+                        <a:rPr sz="700" b="0">
+                          <a:solidFill>
+                            <a:srgbClr val="1F262A"/>
+                          </a:solidFill>
+                          <a:latin typeface="Microsoft YaHei"/>
+                        </a:rPr>
+                        <a:t>3.604</a:t>
+                      </a:r>
+                    </a:p>
+                  </a:txBody>
+                  <a:tcPr>
+                    <a:solidFill>
+                      <a:srgbClr val="FCFDFC"/>
+                    </a:solidFill>
+                  </a:tcPr>
+                </a:tc>
+                <a:tc>
+                  <a:txBody>
+                    <a:bodyPr lIns="27432" rIns="27432" tIns="18288" bIns="18288"/>
+                    <a:lstStyle/>
+                    <a:p>
+                      <a:pPr algn="ctr"/>
+                      <a:r>
+                        <a:rPr sz="700" b="0">
+                          <a:solidFill>
+                            <a:srgbClr val="1F262A"/>
+                          </a:solidFill>
+                          <a:latin typeface="Microsoft YaHei"/>
+                        </a:rPr>
+                        <a:t>0.995716</a:t>
+                      </a:r>
+                    </a:p>
+                  </a:txBody>
+                  <a:tcPr>
+                    <a:solidFill>
+                      <a:srgbClr val="FCFDFC"/>
+                    </a:solidFill>
+                  </a:tcPr>
+                </a:tc>
+                <a:tc>
+                  <a:txBody>
+                    <a:bodyPr lIns="27432" rIns="27432" tIns="18288" bIns="18288"/>
+                    <a:lstStyle/>
+                    <a:p>
+                      <a:pPr algn="ctr"/>
+                      <a:r>
+                        <a:rPr sz="700" b="0">
+                          <a:solidFill>
+                            <a:srgbClr val="1F262A"/>
+                          </a:solidFill>
+                          <a:latin typeface="Microsoft YaHei"/>
+                        </a:rPr>
+                        <a:t>0.961</a:t>
+                      </a:r>
+                    </a:p>
+                  </a:txBody>
+                  <a:tcPr>
+                    <a:solidFill>
+                      <a:srgbClr val="FCFDFC"/>
+                    </a:solidFill>
+                  </a:tcPr>
+                </a:tc>
+              </a:tr>
+              <a:tr h="627018">
+                <a:tc>
+                  <a:txBody>
+                    <a:bodyPr lIns="27432" rIns="27432" tIns="18288" bIns="18288"/>
+                    <a:lstStyle/>
+                    <a:p>
+                      <a:pPr algn="ctr"/>
+                      <a:r>
+                        <a:rPr sz="700" b="0">
+                          <a:solidFill>
+                            <a:srgbClr val="1F262A"/>
+                          </a:solidFill>
+                          <a:latin typeface="Microsoft YaHei"/>
+                        </a:rPr>
+                        <a:t>Hough 边框观测</a:t>
+                      </a:r>
+                    </a:p>
+                  </a:txBody>
+                  <a:tcPr>
+                    <a:solidFill>
+                      <a:srgbClr val="F4F7F6"/>
+                    </a:solidFill>
+                  </a:tcPr>
+                </a:tc>
+                <a:tc>
+                  <a:txBody>
+                    <a:bodyPr lIns="27432" rIns="27432" tIns="18288" bIns="18288"/>
+                    <a:lstStyle/>
+                    <a:p>
+                      <a:pPr algn="ctr"/>
+                      <a:r>
+                        <a:rPr sz="700" b="0">
                           <a:solidFill>
                             <a:srgbClr val="1F262A"/>
                           </a:solidFill>
@@ -4259,13 +4493,13 @@
                     <a:p>
                       <a:pPr algn="ctr"/>
                       <a:r>
-                        <a:rPr sz="800" b="0">
+                        <a:rPr sz="700" b="0">
                           <a:solidFill>
                             <a:srgbClr val="1F262A"/>
                           </a:solidFill>
                           <a:latin typeface="Microsoft YaHei"/>
                         </a:rPr>
-                        <a:t>3.604</a:t>
+                        <a:t>27.335</a:t>
                       </a:r>
                     </a:p>
                   </a:txBody>
@@ -4282,13 +4516,13 @@
                     <a:p>
                       <a:pPr algn="ctr"/>
                       <a:r>
-                        <a:rPr sz="800" b="0">
+                        <a:rPr sz="700" b="0">
                           <a:solidFill>
                             <a:srgbClr val="1F262A"/>
                           </a:solidFill>
                           <a:latin typeface="Microsoft YaHei"/>
                         </a:rPr>
-                        <a:t>0.995716</a:t>
+                        <a:t>0.974200</a:t>
                       </a:r>
                     </a:p>
                   </a:txBody>
@@ -4305,124 +4539,7 @@
                     <a:p>
                       <a:pPr algn="ctr"/>
                       <a:r>
-                        <a:rPr sz="800" b="0">
-                          <a:solidFill>
-                            <a:srgbClr val="1F262A"/>
-                          </a:solidFill>
-                          <a:latin typeface="Microsoft YaHei"/>
-                        </a:rPr>
-                        <a:t>0.961</a:t>
-                      </a:r>
-                    </a:p>
-                  </a:txBody>
-                  <a:tcPr>
-                    <a:solidFill>
-                      <a:srgbClr val="F4F7F6"/>
-                    </a:solidFill>
-                  </a:tcPr>
-                </a:tc>
-              </a:tr>
-              <a:tr h="693420">
-                <a:tc>
-                  <a:txBody>
-                    <a:bodyPr lIns="27432" rIns="27432" tIns="18288" bIns="18288"/>
-                    <a:lstStyle/>
-                    <a:p>
-                      <a:pPr algn="ctr"/>
-                      <a:r>
-                        <a:rPr sz="800" b="0">
-                          <a:solidFill>
-                            <a:srgbClr val="1F262A"/>
-                          </a:solidFill>
-                          <a:latin typeface="Microsoft YaHei"/>
-                        </a:rPr>
-                        <a:t>Hough 边框观测</a:t>
-                      </a:r>
-                    </a:p>
-                  </a:txBody>
-                  <a:tcPr>
-                    <a:solidFill>
-                      <a:srgbClr val="FCFDFC"/>
-                    </a:solidFill>
-                  </a:tcPr>
-                </a:tc>
-                <a:tc>
-                  <a:txBody>
-                    <a:bodyPr lIns="27432" rIns="27432" tIns="18288" bIns="18288"/>
-                    <a:lstStyle/>
-                    <a:p>
-                      <a:pPr algn="ctr"/>
-                      <a:r>
-                        <a:rPr sz="800" b="0">
-                          <a:solidFill>
-                            <a:srgbClr val="1F262A"/>
-                          </a:solidFill>
-                          <a:latin typeface="Microsoft YaHei"/>
-                        </a:rPr>
-                        <a:t>替换 profile</a:t>
-                      </a:r>
-                    </a:p>
-                  </a:txBody>
-                  <a:tcPr>
-                    <a:solidFill>
-                      <a:srgbClr val="FCFDFC"/>
-                    </a:solidFill>
-                  </a:tcPr>
-                </a:tc>
-                <a:tc>
-                  <a:txBody>
-                    <a:bodyPr lIns="27432" rIns="27432" tIns="18288" bIns="18288"/>
-                    <a:lstStyle/>
-                    <a:p>
-                      <a:pPr algn="ctr"/>
-                      <a:r>
-                        <a:rPr sz="800" b="0">
-                          <a:solidFill>
-                            <a:srgbClr val="1F262A"/>
-                          </a:solidFill>
-                          <a:latin typeface="Microsoft YaHei"/>
-                        </a:rPr>
-                        <a:t>27.335</a:t>
-                      </a:r>
-                    </a:p>
-                  </a:txBody>
-                  <a:tcPr>
-                    <a:solidFill>
-                      <a:srgbClr val="FCFDFC"/>
-                    </a:solidFill>
-                  </a:tcPr>
-                </a:tc>
-                <a:tc>
-                  <a:txBody>
-                    <a:bodyPr lIns="27432" rIns="27432" tIns="18288" bIns="18288"/>
-                    <a:lstStyle/>
-                    <a:p>
-                      <a:pPr algn="ctr"/>
-                      <a:r>
-                        <a:rPr sz="800" b="0">
-                          <a:solidFill>
-                            <a:srgbClr val="1F262A"/>
-                          </a:solidFill>
-                          <a:latin typeface="Microsoft YaHei"/>
-                        </a:rPr>
-                        <a:t>0.974200</a:t>
-                      </a:r>
-                    </a:p>
-                  </a:txBody>
-                  <a:tcPr>
-                    <a:solidFill>
-                      <a:srgbClr val="FCFDFC"/>
-                    </a:solidFill>
-                  </a:tcPr>
-                </a:tc>
-                <a:tc>
-                  <a:txBody>
-                    <a:bodyPr lIns="27432" rIns="27432" tIns="18288" bIns="18288"/>
-                    <a:lstStyle/>
-                    <a:p>
-                      <a:pPr algn="ctr"/>
-                      <a:r>
-                        <a:rPr sz="800" b="0">
+                        <a:rPr sz="700" b="0">
                           <a:solidFill>
                             <a:srgbClr val="1F262A"/>
                           </a:solidFill>
@@ -4434,7 +4551,7 @@
                   </a:txBody>
                   <a:tcPr>
                     <a:solidFill>
-                      <a:srgbClr val="FCFDFC"/>
+                      <a:srgbClr val="F4F7F6"/>
                     </a:solidFill>
                   </a:tcPr>
                 </a:tc>
@@ -4452,7 +4569,7 @@
         <p:spPr>
           <a:xfrm>
             <a:off x="8887968" y="1828800"/>
-            <a:ext cx="2606040" cy="1143000"/>
+            <a:ext cx="2606040" cy="1325880"/>
           </a:xfrm>
           <a:prstGeom prst="rect">
             <a:avLst/>
@@ -4497,7 +4614,7 @@
         <p:spPr>
           <a:xfrm>
             <a:off x="8997696" y="1901952"/>
-            <a:ext cx="2386584" cy="1033271"/>
+            <a:ext cx="2386584" cy="1216152"/>
           </a:xfrm>
           <a:prstGeom prst="rect">
             <a:avLst/>
@@ -4518,7 +4635,7 @@
                 </a:solidFill>
                 <a:latin typeface="Microsoft YaHei"/>
               </a:rPr>
-              <a:t>消融只保留当前实现中的可切换模块：LK 诊断、物理边框证据和边框观测器。</a:t>
+              <a:t>主表保留有解释力的当前消融：轨迹滤波、LK 诊断、物理边框证据和边框观测器。</a:t>
             </a:r>
           </a:p>
         </p:txBody>

</xml_diff>